<commit_message>
Integrated Nuclear Reset, fixed Celery hangs, updated UI animations, and added devtools features
</commit_message>
<xml_diff>
--- a/KavinBase_Presentation.pptx
+++ b/KavinBase_Presentation.pptx
@@ -14,6 +14,7 @@
     <p:sldId id="262" r:id="rId13"/>
     <p:sldId id="263" r:id="rId14"/>
     <p:sldId id="264" r:id="rId15"/>
+    <p:sldId id="265" r:id="rId16"/>
   </p:sldIdLst>
   <p:sldSz cx="9144000" cy="6858000" type="screen4x3"/>
   <p:notesSz cx="6858000" cy="9144000"/>
@@ -3151,6 +3152,85 @@
 </p:sld>
 </file>
 
+<file path=ppt/slides/slide10.xml><?xml version="1.0" encoding="utf-8"?>
+<p:sld xmlns:a="http://schemas.openxmlformats.org/drawingml/2006/main" xmlns:p="http://schemas.openxmlformats.org/presentationml/2006/main" xmlns:r="http://schemas.openxmlformats.org/officeDocument/2006/relationships">
+  <p:cSld>
+    <p:spTree>
+      <p:nvGrpSpPr>
+        <p:cNvPr id="1" name=""/>
+        <p:cNvGrpSpPr/>
+        <p:nvPr/>
+      </p:nvGrpSpPr>
+      <p:grpSpPr/>
+      <p:sp>
+        <p:nvSpPr>
+          <p:cNvPr id="2" name="Title 1"/>
+          <p:cNvSpPr>
+            <a:spLocks noGrp="1"/>
+          </p:cNvSpPr>
+          <p:nvPr>
+            <p:ph type="title"/>
+          </p:nvPr>
+        </p:nvSpPr>
+        <p:spPr/>
+        <p:txBody>
+          <a:bodyPr/>
+          <a:lstStyle/>
+          <a:p>
+            <a:r>
+              <a:t>Storage Ecosystem</a:t>
+            </a:r>
+          </a:p>
+        </p:txBody>
+      </p:sp>
+      <p:sp>
+        <p:nvSpPr>
+          <p:cNvPr id="3" name="Content Placeholder 2"/>
+          <p:cNvSpPr>
+            <a:spLocks noGrp="1"/>
+          </p:cNvSpPr>
+          <p:nvPr>
+            <p:ph idx="1"/>
+          </p:nvPr>
+        </p:nvSpPr>
+        <p:spPr/>
+        <p:txBody>
+          <a:bodyPr/>
+          <a:lstStyle/>
+          <a:p>
+            <a:pPr>
+              <a:defRPr sz="1600"/>
+            </a:pPr>
+            <a:r>
+              <a:t>MinIO (Object Stores): Retains raw PDFs and binary blobs isolated from the database.</a:t>
+            </a:r>
+          </a:p>
+          <a:p>
+            <a:pPr>
+              <a:defRPr sz="1600"/>
+            </a:pPr>
+            <a:r>
+              <a:t>PostgreSQL + PGVector (Relational / Vector): Handles user schemas, project models, and the ~384 dimensional vector indexes.</a:t>
+            </a:r>
+          </a:p>
+          <a:p>
+            <a:pPr>
+              <a:defRPr sz="1600"/>
+            </a:pPr>
+            <a:r>
+              <a:t>Redis (Key-Value Keyring): Serves as the high-speed Cache layer tracking streaming states and broker messaging.</a:t>
+            </a:r>
+          </a:p>
+        </p:txBody>
+      </p:sp>
+    </p:spTree>
+  </p:cSld>
+  <p:clrMapOvr>
+    <a:masterClrMapping/>
+  </p:clrMapOvr>
+</p:sld>
+</file>
+
 <file path=ppt/slides/slide2.xml><?xml version="1.0" encoding="utf-8"?>
 <p:sld xmlns:a="http://schemas.openxmlformats.org/drawingml/2006/main" xmlns:p="http://schemas.openxmlformats.org/presentationml/2006/main" xmlns:r="http://schemas.openxmlformats.org/officeDocument/2006/relationships">
   <p:cSld>
@@ -3232,7 +3312,7 @@
       </p:sp>
       <p:pic>
         <p:nvPicPr>
-          <p:cNvPr id="4" name="Picture 3" descr="image.png"/>
+          <p:cNvPr id="4" name="Picture 3" descr="System_Architecture_Graph.png"/>
           <p:cNvPicPr>
             <a:picLocks noChangeAspect="1"/>
           </p:cNvPicPr>
@@ -3247,7 +3327,7 @@
         <p:spPr>
           <a:xfrm>
             <a:off x="1371600" y="3657600"/>
-            <a:ext cx="2946400" cy="2743200"/>
+            <a:ext cx="3700287" cy="2743200"/>
           </a:xfrm>
           <a:prstGeom prst="rect">
             <a:avLst/>
@@ -3343,7 +3423,7 @@
       </p:sp>
       <p:pic>
         <p:nvPicPr>
-          <p:cNvPr id="4" name="Picture 3" descr="image.png"/>
+          <p:cNvPr id="4" name="Picture 3" descr="Ingestion_Pipeline_Graph.png"/>
           <p:cNvPicPr>
             <a:picLocks noChangeAspect="1"/>
           </p:cNvPicPr>
@@ -3358,7 +3438,7 @@
         <p:spPr>
           <a:xfrm>
             <a:off x="1371600" y="3657600"/>
-            <a:ext cx="54922366" cy="2743200"/>
+            <a:ext cx="51859543" cy="2743200"/>
           </a:xfrm>
           <a:prstGeom prst="rect">
             <a:avLst/>
@@ -3454,7 +3534,7 @@
       </p:sp>
       <p:pic>
         <p:nvPicPr>
-          <p:cNvPr id="4" name="Picture 3" descr="image.png"/>
+          <p:cNvPr id="4" name="Picture 3" descr="Query_Pipeline_Graph.png"/>
           <p:cNvPicPr>
             <a:picLocks noChangeAspect="1"/>
           </p:cNvPicPr>
@@ -3469,7 +3549,7 @@
         <p:spPr>
           <a:xfrm>
             <a:off x="1371600" y="3657600"/>
-            <a:ext cx="2686756" cy="2743200"/>
+            <a:ext cx="1698978" cy="2743200"/>
           </a:xfrm>
           <a:prstGeom prst="rect">
             <a:avLst/>
@@ -3510,7 +3590,7 @@
           <a:lstStyle/>
           <a:p>
             <a:r>
-              <a:t>Frontend: Application Dashboard</a:t>
+              <a:t>AI Intelligence Workflow</a:t>
             </a:r>
           </a:p>
         </p:txBody>
@@ -3534,7 +3614,7 @@
               <a:defRPr sz="1600"/>
             </a:pPr>
             <a:r>
-              <a:t>The Dashboard serves as the main command center.</a:t>
+              <a:t>A high-level abstraction of the RAG (Retrieval-Augmented Generation) pipeline.</a:t>
             </a:r>
           </a:p>
           <a:p>
@@ -3542,22 +3622,14 @@
               <a:defRPr sz="1600"/>
             </a:pPr>
             <a:r>
-              <a:t>Pulls real-time project metrics directly from the PostgreSQL instance.</a:t>
-            </a:r>
-          </a:p>
-          <a:p>
-            <a:pPr>
-              <a:defRPr sz="1600"/>
-            </a:pPr>
-            <a:r>
-              <a:t>Secure JWT verification protects layout access across routes.</a:t>
+              <a:t>Demonstrates semantic data streaming off vectors and interacting with the neural LLM endpoint.</a:t>
             </a:r>
           </a:p>
         </p:txBody>
       </p:sp>
       <p:pic>
         <p:nvPicPr>
-          <p:cNvPr id="4" name="Picture 3" descr="dashboard_real.png"/>
+          <p:cNvPr id="4" name="Picture 3" descr="model_workflow_conceptual_1775733330919.png"/>
           <p:cNvPicPr>
             <a:picLocks noChangeAspect="1"/>
           </p:cNvPicPr>
@@ -3572,7 +3644,7 @@
         <p:spPr>
           <a:xfrm>
             <a:off x="1371600" y="3657600"/>
-            <a:ext cx="4876800" cy="2743200"/>
+            <a:ext cx="2743200" cy="2743200"/>
           </a:xfrm>
           <a:prstGeom prst="rect">
             <a:avLst/>
@@ -3613,7 +3685,7 @@
           <a:lstStyle/>
           <a:p>
             <a:r>
-              <a:t>Frontend: Chat Workspace</a:t>
+              <a:t>Frontend: Application Dashboard</a:t>
             </a:r>
           </a:p>
         </p:txBody>
@@ -3637,7 +3709,7 @@
               <a:defRPr sz="1600"/>
             </a:pPr>
             <a:r>
-              <a:t>Real-time intelligence retrieval center.</a:t>
+              <a:t>The Dashboard serves as the main command center.</a:t>
             </a:r>
           </a:p>
           <a:p>
@@ -3645,7 +3717,7 @@
               <a:defRPr sz="1600"/>
             </a:pPr>
             <a:r>
-              <a:t>Maintains continuous SSE (Server-Sent Events) links with the LLM backend for token-by-token rendering.</a:t>
+              <a:t>Pulls real-time project metrics directly from the PostgreSQL instance.</a:t>
             </a:r>
           </a:p>
           <a:p>
@@ -3653,14 +3725,14 @@
               <a:defRPr sz="1600"/>
             </a:pPr>
             <a:r>
-              <a:t>Embeds technical Markdown, Tables, and citations safely.</a:t>
+              <a:t>Secure JWT verification protects layout access across routes.</a:t>
             </a:r>
           </a:p>
         </p:txBody>
       </p:sp>
       <p:pic>
         <p:nvPicPr>
-          <p:cNvPr id="4" name="Picture 3" descr="chat_real.png"/>
+          <p:cNvPr id="4" name="Picture 3" descr="dashboard_real.png"/>
           <p:cNvPicPr>
             <a:picLocks noChangeAspect="1"/>
           </p:cNvPicPr>
@@ -3716,7 +3788,7 @@
           <a:lstStyle/>
           <a:p>
             <a:r>
-              <a:t>Frontend: Projects Hub</a:t>
+              <a:t>Frontend: Chat Workspace</a:t>
             </a:r>
           </a:p>
         </p:txBody>
@@ -3740,7 +3812,7 @@
               <a:defRPr sz="1600"/>
             </a:pPr>
             <a:r>
-              <a:t>Document indexing and status tracking interface.</a:t>
+              <a:t>Real-time intelligence retrieval center.</a:t>
             </a:r>
           </a:p>
           <a:p>
@@ -3748,7 +3820,15 @@
               <a:defRPr sz="1600"/>
             </a:pPr>
             <a:r>
-              <a:t>Monitors active celery worker tasks and asynchronous indexing via simple UI indicators.</a:t>
+              <a:t>Maintains continuous SSE (Server-Sent Events) links with the LLM backend for token-by-token rendering.</a:t>
+            </a:r>
+          </a:p>
+          <a:p>
+            <a:pPr>
+              <a:defRPr sz="1600"/>
+            </a:pPr>
+            <a:r>
+              <a:t>Embeds technical Markdown, Tables, and citations safely.</a:t>
             </a:r>
           </a:p>
         </p:txBody>
@@ -3811,6 +3891,101 @@
           <a:lstStyle/>
           <a:p>
             <a:r>
+              <a:t>Frontend: Projects Hub</a:t>
+            </a:r>
+          </a:p>
+        </p:txBody>
+      </p:sp>
+      <p:sp>
+        <p:nvSpPr>
+          <p:cNvPr id="3" name="Content Placeholder 2"/>
+          <p:cNvSpPr>
+            <a:spLocks noGrp="1"/>
+          </p:cNvSpPr>
+          <p:nvPr>
+            <p:ph idx="1"/>
+          </p:nvPr>
+        </p:nvSpPr>
+        <p:spPr/>
+        <p:txBody>
+          <a:bodyPr/>
+          <a:lstStyle/>
+          <a:p>
+            <a:pPr>
+              <a:defRPr sz="1600"/>
+            </a:pPr>
+            <a:r>
+              <a:t>Document indexing and status tracking interface.</a:t>
+            </a:r>
+          </a:p>
+          <a:p>
+            <a:pPr>
+              <a:defRPr sz="1600"/>
+            </a:pPr>
+            <a:r>
+              <a:t>Monitors active celery worker tasks and asynchronous indexing via simple UI indicators.</a:t>
+            </a:r>
+          </a:p>
+        </p:txBody>
+      </p:sp>
+      <p:pic>
+        <p:nvPicPr>
+          <p:cNvPr id="4" name="Picture 3" descr="chat_real.png"/>
+          <p:cNvPicPr>
+            <a:picLocks noChangeAspect="1"/>
+          </p:cNvPicPr>
+          <p:nvPr/>
+        </p:nvPicPr>
+        <p:blipFill>
+          <a:blip r:embed="rId2"/>
+          <a:stretch>
+            <a:fillRect/>
+          </a:stretch>
+        </p:blipFill>
+        <p:spPr>
+          <a:xfrm>
+            <a:off x="1371600" y="3657600"/>
+            <a:ext cx="4876800" cy="2743200"/>
+          </a:xfrm>
+          <a:prstGeom prst="rect">
+            <a:avLst/>
+          </a:prstGeom>
+        </p:spPr>
+      </p:pic>
+    </p:spTree>
+  </p:cSld>
+  <p:clrMapOvr>
+    <a:masterClrMapping/>
+  </p:clrMapOvr>
+</p:sld>
+</file>
+
+<file path=ppt/slides/slide9.xml><?xml version="1.0" encoding="utf-8"?>
+<p:sld xmlns:a="http://schemas.openxmlformats.org/drawingml/2006/main" xmlns:p="http://schemas.openxmlformats.org/presentationml/2006/main" xmlns:r="http://schemas.openxmlformats.org/officeDocument/2006/relationships">
+  <p:cSld>
+    <p:spTree>
+      <p:nvGrpSpPr>
+        <p:cNvPr id="1" name=""/>
+        <p:cNvGrpSpPr/>
+        <p:nvPr/>
+      </p:nvGrpSpPr>
+      <p:grpSpPr/>
+      <p:sp>
+        <p:nvSpPr>
+          <p:cNvPr id="2" name="Title 1"/>
+          <p:cNvSpPr>
+            <a:spLocks noGrp="1"/>
+          </p:cNvSpPr>
+          <p:nvPr>
+            <p:ph type="title"/>
+          </p:nvPr>
+        </p:nvSpPr>
+        <p:spPr/>
+        <p:txBody>
+          <a:bodyPr/>
+          <a:lstStyle/>
+          <a:p>
+            <a:r>
               <a:t>Backend: API Exposure</a:t>
             </a:r>
           </a:p>
@@ -3880,85 +4055,6 @@
           </a:prstGeom>
         </p:spPr>
       </p:pic>
-    </p:spTree>
-  </p:cSld>
-  <p:clrMapOvr>
-    <a:masterClrMapping/>
-  </p:clrMapOvr>
-</p:sld>
-</file>
-
-<file path=ppt/slides/slide9.xml><?xml version="1.0" encoding="utf-8"?>
-<p:sld xmlns:a="http://schemas.openxmlformats.org/drawingml/2006/main" xmlns:p="http://schemas.openxmlformats.org/presentationml/2006/main" xmlns:r="http://schemas.openxmlformats.org/officeDocument/2006/relationships">
-  <p:cSld>
-    <p:spTree>
-      <p:nvGrpSpPr>
-        <p:cNvPr id="1" name=""/>
-        <p:cNvGrpSpPr/>
-        <p:nvPr/>
-      </p:nvGrpSpPr>
-      <p:grpSpPr/>
-      <p:sp>
-        <p:nvSpPr>
-          <p:cNvPr id="2" name="Title 1"/>
-          <p:cNvSpPr>
-            <a:spLocks noGrp="1"/>
-          </p:cNvSpPr>
-          <p:nvPr>
-            <p:ph type="title"/>
-          </p:nvPr>
-        </p:nvSpPr>
-        <p:spPr/>
-        <p:txBody>
-          <a:bodyPr/>
-          <a:lstStyle/>
-          <a:p>
-            <a:r>
-              <a:t>Storage Ecosystem</a:t>
-            </a:r>
-          </a:p>
-        </p:txBody>
-      </p:sp>
-      <p:sp>
-        <p:nvSpPr>
-          <p:cNvPr id="3" name="Content Placeholder 2"/>
-          <p:cNvSpPr>
-            <a:spLocks noGrp="1"/>
-          </p:cNvSpPr>
-          <p:nvPr>
-            <p:ph idx="1"/>
-          </p:nvPr>
-        </p:nvSpPr>
-        <p:spPr/>
-        <p:txBody>
-          <a:bodyPr/>
-          <a:lstStyle/>
-          <a:p>
-            <a:pPr>
-              <a:defRPr sz="1600"/>
-            </a:pPr>
-            <a:r>
-              <a:t>MinIO (Object Stores): Retains raw PDFs and binary blobs isolated from the database.</a:t>
-            </a:r>
-          </a:p>
-          <a:p>
-            <a:pPr>
-              <a:defRPr sz="1600"/>
-            </a:pPr>
-            <a:r>
-              <a:t>PostgreSQL + PGVector (Relational / Vector): Handles user schemas, project models, and the ~384 dimensional vector indexes.</a:t>
-            </a:r>
-          </a:p>
-          <a:p>
-            <a:pPr>
-              <a:defRPr sz="1600"/>
-            </a:pPr>
-            <a:r>
-              <a:t>Redis (Key-Value Keyring): Serves as the high-speed Cache layer tracking streaming states and broker messaging.</a:t>
-            </a:r>
-          </a:p>
-        </p:txBody>
-      </p:sp>
     </p:spTree>
   </p:cSld>
   <p:clrMapOvr>

</xml_diff>